<commit_message>
Replace slides with Final Slides + add ready-to-run demo notebook
- Replaced slides.pdf and slides.pptx with team's Final Slides
- Added MiniClaw_Demo.ipynb: Jupyter notebook with pre-rendered outputs
  that displays immediately on GitHub — click into it during presentation
  Part 1: Six key linkage positions with SolidWorks-style rendering
  Part 2: compute_transmission_angle() tool call comparing 3 designs
  Part 3: Transmission angle comparison chart
  All outputs pre-rendered so it works without running any code

Co-Authored-By: David Ricciotti <davidr73@uw.edu>
</commit_message>
<xml_diff>
--- a/MP5/slides.pptx
+++ b/MP5/slides.pptx
@@ -5,20 +5,20 @@
     <p:sldMasterId id="2147483648" r:id="rId1"/>
   </p:sldMasterIdLst>
   <p:sldIdLst>
-    <p:sldId id="256" r:id="rId7"/>
-    <p:sldId id="257" r:id="rId8"/>
-    <p:sldId id="258" r:id="rId9"/>
-    <p:sldId id="259" r:id="rId10"/>
-    <p:sldId id="260" r:id="rId11"/>
-    <p:sldId id="261" r:id="rId12"/>
-    <p:sldId id="262" r:id="rId13"/>
-    <p:sldId id="263" r:id="rId14"/>
-    <p:sldId id="264" r:id="rId15"/>
-    <p:sldId id="265" r:id="rId16"/>
-    <p:sldId id="266" r:id="rId17"/>
-    <p:sldId id="267" r:id="rId18"/>
+    <p:sldId id="256" r:id="rId2"/>
+    <p:sldId id="257" r:id="rId3"/>
+    <p:sldId id="258" r:id="rId4"/>
+    <p:sldId id="259" r:id="rId5"/>
+    <p:sldId id="260" r:id="rId6"/>
+    <p:sldId id="261" r:id="rId7"/>
+    <p:sldId id="262" r:id="rId8"/>
+    <p:sldId id="263" r:id="rId9"/>
+    <p:sldId id="264" r:id="rId10"/>
+    <p:sldId id="265" r:id="rId11"/>
+    <p:sldId id="266" r:id="rId12"/>
+    <p:sldId id="267" r:id="rId13"/>
   </p:sldIdLst>
-  <p:sldSz cx="12191695" cy="6858000" type="screen4x3"/>
+  <p:sldSz cx="12192000" cy="6858000"/>
   <p:notesSz cx="6858000" cy="9144000"/>
   <p:defaultTextStyle>
     <a:defPPr>
@@ -115,6 +115,22 @@
       </a:defRPr>
     </a:lvl9pPr>
   </p:defaultTextStyle>
+  <p:extLst>
+    <p:ext uri="{EFAFB233-063F-42B5-8137-9DF3F51BA10A}">
+      <p15:sldGuideLst xmlns:p15="http://schemas.microsoft.com/office/powerpoint/2012/main">
+        <p15:guide id="1" orient="horz" pos="2160">
+          <p15:clr>
+            <a:srgbClr val="A4A3A4"/>
+          </p15:clr>
+        </p15:guide>
+        <p15:guide id="2" pos="2880">
+          <p15:clr>
+            <a:srgbClr val="A4A3A4"/>
+          </p15:clr>
+        </p15:guide>
+      </p15:sldGuideLst>
+    </p:ext>
+  </p:extLst>
 </p:presentation>
 </file>
 
@@ -156,10 +172,9 @@
           <a:lstStyle/>
           <a:p>
             <a:r>
-              <a:rPr lang="en-US" smtClean="0"/>
+              <a:rPr lang="en-US"/>
               <a:t>Click to edit Master title style</a:t>
             </a:r>
-            <a:endParaRPr lang="en-US"/>
           </a:p>
         </p:txBody>
       </p:sp>
@@ -275,10 +290,9 @@
           </a:lstStyle>
           <a:p>
             <a:r>
-              <a:rPr lang="en-US" smtClean="0"/>
+              <a:rPr lang="en-US"/>
               <a:t>Click to edit Master subtitle style</a:t>
             </a:r>
-            <a:endParaRPr lang="en-US"/>
           </a:p>
         </p:txBody>
       </p:sp>
@@ -299,7 +313,7 @@
           <a:p>
             <a:fld id="{5BCAD085-E8A6-8845-BD4E-CB4CCA059FC4}" type="datetimeFigureOut">
               <a:rPr lang="en-US" smtClean="0"/>
-              <a:t>1/27/13</a:t>
+              <a:t>5/28/2026</a:t>
             </a:fld>
             <a:endParaRPr lang="en-US"/>
           </a:p>
@@ -393,10 +407,9 @@
           <a:lstStyle/>
           <a:p>
             <a:r>
-              <a:rPr lang="en-US" smtClean="0"/>
+              <a:rPr lang="en-US"/>
               <a:t>Click to edit Master title style</a:t>
             </a:r>
-            <a:endParaRPr lang="en-US"/>
           </a:p>
         </p:txBody>
       </p:sp>
@@ -417,38 +430,37 @@
           <a:p>
             <a:pPr lvl="0"/>
             <a:r>
-              <a:rPr lang="en-US" smtClean="0"/>
+              <a:rPr lang="en-US"/>
               <a:t>Click to edit Master text styles</a:t>
             </a:r>
           </a:p>
           <a:p>
             <a:pPr lvl="1"/>
             <a:r>
-              <a:rPr lang="en-US" smtClean="0"/>
+              <a:rPr lang="en-US"/>
               <a:t>Second level</a:t>
             </a:r>
           </a:p>
           <a:p>
             <a:pPr lvl="2"/>
             <a:r>
-              <a:rPr lang="en-US" smtClean="0"/>
+              <a:rPr lang="en-US"/>
               <a:t>Third level</a:t>
             </a:r>
           </a:p>
           <a:p>
             <a:pPr lvl="3"/>
             <a:r>
-              <a:rPr lang="en-US" smtClean="0"/>
+              <a:rPr lang="en-US"/>
               <a:t>Fourth level</a:t>
             </a:r>
           </a:p>
           <a:p>
             <a:pPr lvl="4"/>
             <a:r>
-              <a:rPr lang="en-US" smtClean="0"/>
+              <a:rPr lang="en-US"/>
               <a:t>Fifth level</a:t>
             </a:r>
-            <a:endParaRPr lang="en-US"/>
           </a:p>
         </p:txBody>
       </p:sp>
@@ -469,7 +481,7 @@
           <a:p>
             <a:fld id="{5BCAD085-E8A6-8845-BD4E-CB4CCA059FC4}" type="datetimeFigureOut">
               <a:rPr lang="en-US" smtClean="0"/>
-              <a:t>1/27/13</a:t>
+              <a:t>5/28/2026</a:t>
             </a:fld>
             <a:endParaRPr lang="en-US"/>
           </a:p>
@@ -568,10 +580,9 @@
           <a:lstStyle/>
           <a:p>
             <a:r>
-              <a:rPr lang="en-US" smtClean="0"/>
+              <a:rPr lang="en-US"/>
               <a:t>Click to edit Master title style</a:t>
             </a:r>
-            <a:endParaRPr lang="en-US"/>
           </a:p>
         </p:txBody>
       </p:sp>
@@ -597,38 +608,37 @@
           <a:p>
             <a:pPr lvl="0"/>
             <a:r>
-              <a:rPr lang="en-US" smtClean="0"/>
+              <a:rPr lang="en-US"/>
               <a:t>Click to edit Master text styles</a:t>
             </a:r>
           </a:p>
           <a:p>
             <a:pPr lvl="1"/>
             <a:r>
-              <a:rPr lang="en-US" smtClean="0"/>
+              <a:rPr lang="en-US"/>
               <a:t>Second level</a:t>
             </a:r>
           </a:p>
           <a:p>
             <a:pPr lvl="2"/>
             <a:r>
-              <a:rPr lang="en-US" smtClean="0"/>
+              <a:rPr lang="en-US"/>
               <a:t>Third level</a:t>
             </a:r>
           </a:p>
           <a:p>
             <a:pPr lvl="3"/>
             <a:r>
-              <a:rPr lang="en-US" smtClean="0"/>
+              <a:rPr lang="en-US"/>
               <a:t>Fourth level</a:t>
             </a:r>
           </a:p>
           <a:p>
             <a:pPr lvl="4"/>
             <a:r>
-              <a:rPr lang="en-US" smtClean="0"/>
+              <a:rPr lang="en-US"/>
               <a:t>Fifth level</a:t>
             </a:r>
-            <a:endParaRPr lang="en-US"/>
           </a:p>
         </p:txBody>
       </p:sp>
@@ -649,7 +659,7 @@
           <a:p>
             <a:fld id="{5BCAD085-E8A6-8845-BD4E-CB4CCA059FC4}" type="datetimeFigureOut">
               <a:rPr lang="en-US" smtClean="0"/>
-              <a:t>1/27/13</a:t>
+              <a:t>5/28/2026</a:t>
             </a:fld>
             <a:endParaRPr lang="en-US"/>
           </a:p>
@@ -743,10 +753,9 @@
           <a:lstStyle/>
           <a:p>
             <a:r>
-              <a:rPr lang="en-US" smtClean="0"/>
+              <a:rPr lang="en-US"/>
               <a:t>Click to edit Master title style</a:t>
             </a:r>
-            <a:endParaRPr lang="en-US"/>
           </a:p>
         </p:txBody>
       </p:sp>
@@ -767,38 +776,37 @@
           <a:p>
             <a:pPr lvl="0"/>
             <a:r>
-              <a:rPr lang="en-US" smtClean="0"/>
+              <a:rPr lang="en-US"/>
               <a:t>Click to edit Master text styles</a:t>
             </a:r>
           </a:p>
           <a:p>
             <a:pPr lvl="1"/>
             <a:r>
-              <a:rPr lang="en-US" smtClean="0"/>
+              <a:rPr lang="en-US"/>
               <a:t>Second level</a:t>
             </a:r>
           </a:p>
           <a:p>
             <a:pPr lvl="2"/>
             <a:r>
-              <a:rPr lang="en-US" smtClean="0"/>
+              <a:rPr lang="en-US"/>
               <a:t>Third level</a:t>
             </a:r>
           </a:p>
           <a:p>
             <a:pPr lvl="3"/>
             <a:r>
-              <a:rPr lang="en-US" smtClean="0"/>
+              <a:rPr lang="en-US"/>
               <a:t>Fourth level</a:t>
             </a:r>
           </a:p>
           <a:p>
             <a:pPr lvl="4"/>
             <a:r>
-              <a:rPr lang="en-US" smtClean="0"/>
+              <a:rPr lang="en-US"/>
               <a:t>Fifth level</a:t>
             </a:r>
-            <a:endParaRPr lang="en-US"/>
           </a:p>
         </p:txBody>
       </p:sp>
@@ -819,7 +827,7 @@
           <a:p>
             <a:fld id="{5BCAD085-E8A6-8845-BD4E-CB4CCA059FC4}" type="datetimeFigureOut">
               <a:rPr lang="en-US" smtClean="0"/>
-              <a:t>1/27/13</a:t>
+              <a:t>5/28/2026</a:t>
             </a:fld>
             <a:endParaRPr lang="en-US"/>
           </a:p>
@@ -922,10 +930,9 @@
           </a:lstStyle>
           <a:p>
             <a:r>
-              <a:rPr lang="en-US" smtClean="0"/>
+              <a:rPr lang="en-US"/>
               <a:t>Click to edit Master title style</a:t>
             </a:r>
-            <a:endParaRPr lang="en-US"/>
           </a:p>
         </p:txBody>
       </p:sp>
@@ -1042,7 +1049,7 @@
           <a:p>
             <a:pPr lvl="0"/>
             <a:r>
-              <a:rPr lang="en-US" smtClean="0"/>
+              <a:rPr lang="en-US"/>
               <a:t>Click to edit Master text styles</a:t>
             </a:r>
           </a:p>
@@ -1065,7 +1072,7 @@
           <a:p>
             <a:fld id="{5BCAD085-E8A6-8845-BD4E-CB4CCA059FC4}" type="datetimeFigureOut">
               <a:rPr lang="en-US" smtClean="0"/>
-              <a:t>1/27/13</a:t>
+              <a:t>5/28/2026</a:t>
             </a:fld>
             <a:endParaRPr lang="en-US"/>
           </a:p>
@@ -1159,10 +1166,9 @@
           <a:lstStyle/>
           <a:p>
             <a:r>
-              <a:rPr lang="en-US" smtClean="0"/>
+              <a:rPr lang="en-US"/>
               <a:t>Click to edit Master title style</a:t>
             </a:r>
-            <a:endParaRPr lang="en-US"/>
           </a:p>
         </p:txBody>
       </p:sp>
@@ -1216,38 +1222,37 @@
           <a:p>
             <a:pPr lvl="0"/>
             <a:r>
-              <a:rPr lang="en-US" smtClean="0"/>
+              <a:rPr lang="en-US"/>
               <a:t>Click to edit Master text styles</a:t>
             </a:r>
           </a:p>
           <a:p>
             <a:pPr lvl="1"/>
             <a:r>
-              <a:rPr lang="en-US" smtClean="0"/>
+              <a:rPr lang="en-US"/>
               <a:t>Second level</a:t>
             </a:r>
           </a:p>
           <a:p>
             <a:pPr lvl="2"/>
             <a:r>
-              <a:rPr lang="en-US" smtClean="0"/>
+              <a:rPr lang="en-US"/>
               <a:t>Third level</a:t>
             </a:r>
           </a:p>
           <a:p>
             <a:pPr lvl="3"/>
             <a:r>
-              <a:rPr lang="en-US" smtClean="0"/>
+              <a:rPr lang="en-US"/>
               <a:t>Fourth level</a:t>
             </a:r>
           </a:p>
           <a:p>
             <a:pPr lvl="4"/>
             <a:r>
-              <a:rPr lang="en-US" smtClean="0"/>
+              <a:rPr lang="en-US"/>
               <a:t>Fifth level</a:t>
             </a:r>
-            <a:endParaRPr lang="en-US"/>
           </a:p>
         </p:txBody>
       </p:sp>
@@ -1301,38 +1306,37 @@
           <a:p>
             <a:pPr lvl="0"/>
             <a:r>
-              <a:rPr lang="en-US" smtClean="0"/>
+              <a:rPr lang="en-US"/>
               <a:t>Click to edit Master text styles</a:t>
             </a:r>
           </a:p>
           <a:p>
             <a:pPr lvl="1"/>
             <a:r>
-              <a:rPr lang="en-US" smtClean="0"/>
+              <a:rPr lang="en-US"/>
               <a:t>Second level</a:t>
             </a:r>
           </a:p>
           <a:p>
             <a:pPr lvl="2"/>
             <a:r>
-              <a:rPr lang="en-US" smtClean="0"/>
+              <a:rPr lang="en-US"/>
               <a:t>Third level</a:t>
             </a:r>
           </a:p>
           <a:p>
             <a:pPr lvl="3"/>
             <a:r>
-              <a:rPr lang="en-US" smtClean="0"/>
+              <a:rPr lang="en-US"/>
               <a:t>Fourth level</a:t>
             </a:r>
           </a:p>
           <a:p>
             <a:pPr lvl="4"/>
             <a:r>
-              <a:rPr lang="en-US" smtClean="0"/>
+              <a:rPr lang="en-US"/>
               <a:t>Fifth level</a:t>
             </a:r>
-            <a:endParaRPr lang="en-US"/>
           </a:p>
         </p:txBody>
       </p:sp>
@@ -1353,7 +1357,7 @@
           <a:p>
             <a:fld id="{5BCAD085-E8A6-8845-BD4E-CB4CCA059FC4}" type="datetimeFigureOut">
               <a:rPr lang="en-US" smtClean="0"/>
-              <a:t>1/27/13</a:t>
+              <a:t>5/28/2026</a:t>
             </a:fld>
             <a:endParaRPr lang="en-US"/>
           </a:p>
@@ -1451,10 +1455,9 @@
           </a:lstStyle>
           <a:p>
             <a:r>
-              <a:rPr lang="en-US" smtClean="0"/>
+              <a:rPr lang="en-US"/>
               <a:t>Click to edit Master title style</a:t>
             </a:r>
-            <a:endParaRPr lang="en-US"/>
           </a:p>
         </p:txBody>
       </p:sp>
@@ -1517,7 +1520,7 @@
           <a:p>
             <a:pPr lvl="0"/>
             <a:r>
-              <a:rPr lang="en-US" smtClean="0"/>
+              <a:rPr lang="en-US"/>
               <a:t>Click to edit Master text styles</a:t>
             </a:r>
           </a:p>
@@ -1573,38 +1576,37 @@
           <a:p>
             <a:pPr lvl="0"/>
             <a:r>
-              <a:rPr lang="en-US" smtClean="0"/>
+              <a:rPr lang="en-US"/>
               <a:t>Click to edit Master text styles</a:t>
             </a:r>
           </a:p>
           <a:p>
             <a:pPr lvl="1"/>
             <a:r>
-              <a:rPr lang="en-US" smtClean="0"/>
+              <a:rPr lang="en-US"/>
               <a:t>Second level</a:t>
             </a:r>
           </a:p>
           <a:p>
             <a:pPr lvl="2"/>
             <a:r>
-              <a:rPr lang="en-US" smtClean="0"/>
+              <a:rPr lang="en-US"/>
               <a:t>Third level</a:t>
             </a:r>
           </a:p>
           <a:p>
             <a:pPr lvl="3"/>
             <a:r>
-              <a:rPr lang="en-US" smtClean="0"/>
+              <a:rPr lang="en-US"/>
               <a:t>Fourth level</a:t>
             </a:r>
           </a:p>
           <a:p>
             <a:pPr lvl="4"/>
             <a:r>
-              <a:rPr lang="en-US" smtClean="0"/>
+              <a:rPr lang="en-US"/>
               <a:t>Fifth level</a:t>
             </a:r>
-            <a:endParaRPr lang="en-US"/>
           </a:p>
         </p:txBody>
       </p:sp>
@@ -1667,7 +1669,7 @@
           <a:p>
             <a:pPr lvl="0"/>
             <a:r>
-              <a:rPr lang="en-US" smtClean="0"/>
+              <a:rPr lang="en-US"/>
               <a:t>Click to edit Master text styles</a:t>
             </a:r>
           </a:p>
@@ -1723,38 +1725,37 @@
           <a:p>
             <a:pPr lvl="0"/>
             <a:r>
-              <a:rPr lang="en-US" smtClean="0"/>
+              <a:rPr lang="en-US"/>
               <a:t>Click to edit Master text styles</a:t>
             </a:r>
           </a:p>
           <a:p>
             <a:pPr lvl="1"/>
             <a:r>
-              <a:rPr lang="en-US" smtClean="0"/>
+              <a:rPr lang="en-US"/>
               <a:t>Second level</a:t>
             </a:r>
           </a:p>
           <a:p>
             <a:pPr lvl="2"/>
             <a:r>
-              <a:rPr lang="en-US" smtClean="0"/>
+              <a:rPr lang="en-US"/>
               <a:t>Third level</a:t>
             </a:r>
           </a:p>
           <a:p>
             <a:pPr lvl="3"/>
             <a:r>
-              <a:rPr lang="en-US" smtClean="0"/>
+              <a:rPr lang="en-US"/>
               <a:t>Fourth level</a:t>
             </a:r>
           </a:p>
           <a:p>
             <a:pPr lvl="4"/>
             <a:r>
-              <a:rPr lang="en-US" smtClean="0"/>
+              <a:rPr lang="en-US"/>
               <a:t>Fifth level</a:t>
             </a:r>
-            <a:endParaRPr lang="en-US"/>
           </a:p>
         </p:txBody>
       </p:sp>
@@ -1775,7 +1776,7 @@
           <a:p>
             <a:fld id="{5BCAD085-E8A6-8845-BD4E-CB4CCA059FC4}" type="datetimeFigureOut">
               <a:rPr lang="en-US" smtClean="0"/>
-              <a:t>1/27/13</a:t>
+              <a:t>5/28/2026</a:t>
             </a:fld>
             <a:endParaRPr lang="en-US"/>
           </a:p>
@@ -1869,10 +1870,9 @@
           <a:lstStyle/>
           <a:p>
             <a:r>
-              <a:rPr lang="en-US" smtClean="0"/>
+              <a:rPr lang="en-US"/>
               <a:t>Click to edit Master title style</a:t>
             </a:r>
-            <a:endParaRPr lang="en-US"/>
           </a:p>
         </p:txBody>
       </p:sp>
@@ -1893,7 +1893,7 @@
           <a:p>
             <a:fld id="{5BCAD085-E8A6-8845-BD4E-CB4CCA059FC4}" type="datetimeFigureOut">
               <a:rPr lang="en-US" smtClean="0"/>
-              <a:t>1/27/13</a:t>
+              <a:t>5/28/2026</a:t>
             </a:fld>
             <a:endParaRPr lang="en-US"/>
           </a:p>
@@ -1988,7 +1988,7 @@
           <a:p>
             <a:fld id="{5BCAD085-E8A6-8845-BD4E-CB4CCA059FC4}" type="datetimeFigureOut">
               <a:rPr lang="en-US" smtClean="0"/>
-              <a:t>1/27/13</a:t>
+              <a:t>5/28/2026</a:t>
             </a:fld>
             <a:endParaRPr lang="en-US"/>
           </a:p>
@@ -2091,10 +2091,9 @@
           </a:lstStyle>
           <a:p>
             <a:r>
-              <a:rPr lang="en-US" smtClean="0"/>
+              <a:rPr lang="en-US"/>
               <a:t>Click to edit Master title style</a:t>
             </a:r>
-            <a:endParaRPr lang="en-US"/>
           </a:p>
         </p:txBody>
       </p:sp>
@@ -2148,38 +2147,37 @@
           <a:p>
             <a:pPr lvl="0"/>
             <a:r>
-              <a:rPr lang="en-US" smtClean="0"/>
+              <a:rPr lang="en-US"/>
               <a:t>Click to edit Master text styles</a:t>
             </a:r>
           </a:p>
           <a:p>
             <a:pPr lvl="1"/>
             <a:r>
-              <a:rPr lang="en-US" smtClean="0"/>
+              <a:rPr lang="en-US"/>
               <a:t>Second level</a:t>
             </a:r>
           </a:p>
           <a:p>
             <a:pPr lvl="2"/>
             <a:r>
-              <a:rPr lang="en-US" smtClean="0"/>
+              <a:rPr lang="en-US"/>
               <a:t>Third level</a:t>
             </a:r>
           </a:p>
           <a:p>
             <a:pPr lvl="3"/>
             <a:r>
-              <a:rPr lang="en-US" smtClean="0"/>
+              <a:rPr lang="en-US"/>
               <a:t>Fourth level</a:t>
             </a:r>
           </a:p>
           <a:p>
             <a:pPr lvl="4"/>
             <a:r>
-              <a:rPr lang="en-US" smtClean="0"/>
+              <a:rPr lang="en-US"/>
               <a:t>Fifth level</a:t>
             </a:r>
-            <a:endParaRPr lang="en-US"/>
           </a:p>
         </p:txBody>
       </p:sp>
@@ -2242,7 +2240,7 @@
           <a:p>
             <a:pPr lvl="0"/>
             <a:r>
-              <a:rPr lang="en-US" smtClean="0"/>
+              <a:rPr lang="en-US"/>
               <a:t>Click to edit Master text styles</a:t>
             </a:r>
           </a:p>
@@ -2265,7 +2263,7 @@
           <a:p>
             <a:fld id="{5BCAD085-E8A6-8845-BD4E-CB4CCA059FC4}" type="datetimeFigureOut">
               <a:rPr lang="en-US" smtClean="0"/>
-              <a:t>1/27/13</a:t>
+              <a:t>5/28/2026</a:t>
             </a:fld>
             <a:endParaRPr lang="en-US"/>
           </a:p>
@@ -2368,10 +2366,9 @@
           </a:lstStyle>
           <a:p>
             <a:r>
-              <a:rPr lang="en-US" smtClean="0"/>
+              <a:rPr lang="en-US"/>
               <a:t>Click to edit Master title style</a:t>
             </a:r>
-            <a:endParaRPr lang="en-US"/>
           </a:p>
         </p:txBody>
       </p:sp>
@@ -2495,7 +2492,7 @@
           <a:p>
             <a:pPr lvl="0"/>
             <a:r>
-              <a:rPr lang="en-US" smtClean="0"/>
+              <a:rPr lang="en-US"/>
               <a:t>Click to edit Master text styles</a:t>
             </a:r>
           </a:p>
@@ -2518,7 +2515,7 @@
           <a:p>
             <a:fld id="{5BCAD085-E8A6-8845-BD4E-CB4CCA059FC4}" type="datetimeFigureOut">
               <a:rPr lang="en-US" smtClean="0"/>
-              <a:t>1/27/13</a:t>
+              <a:t>5/28/2026</a:t>
             </a:fld>
             <a:endParaRPr lang="en-US"/>
           </a:p>
@@ -2627,10 +2624,9 @@
           <a:lstStyle/>
           <a:p>
             <a:r>
-              <a:rPr lang="en-US" smtClean="0"/>
+              <a:rPr lang="en-US"/>
               <a:t>Click to edit Master title style</a:t>
             </a:r>
-            <a:endParaRPr lang="en-US"/>
           </a:p>
         </p:txBody>
       </p:sp>
@@ -2661,38 +2657,37 @@
           <a:p>
             <a:pPr lvl="0"/>
             <a:r>
-              <a:rPr lang="en-US" smtClean="0"/>
+              <a:rPr lang="en-US"/>
               <a:t>Click to edit Master text styles</a:t>
             </a:r>
           </a:p>
           <a:p>
             <a:pPr lvl="1"/>
             <a:r>
-              <a:rPr lang="en-US" smtClean="0"/>
+              <a:rPr lang="en-US"/>
               <a:t>Second level</a:t>
             </a:r>
           </a:p>
           <a:p>
             <a:pPr lvl="2"/>
             <a:r>
-              <a:rPr lang="en-US" smtClean="0"/>
+              <a:rPr lang="en-US"/>
               <a:t>Third level</a:t>
             </a:r>
           </a:p>
           <a:p>
             <a:pPr lvl="3"/>
             <a:r>
-              <a:rPr lang="en-US" smtClean="0"/>
+              <a:rPr lang="en-US"/>
               <a:t>Fourth level</a:t>
             </a:r>
           </a:p>
           <a:p>
             <a:pPr lvl="4"/>
             <a:r>
-              <a:rPr lang="en-US" smtClean="0"/>
+              <a:rPr lang="en-US"/>
               <a:t>Fifth level</a:t>
             </a:r>
-            <a:endParaRPr lang="en-US"/>
           </a:p>
         </p:txBody>
       </p:sp>
@@ -2731,7 +2726,7 @@
           <a:p>
             <a:fld id="{5BCAD085-E8A6-8845-BD4E-CB4CCA059FC4}" type="datetimeFigureOut">
               <a:rPr lang="en-US" smtClean="0"/>
-              <a:t>1/27/13</a:t>
+              <a:t>5/28/2026</a:t>
             </a:fld>
             <a:endParaRPr lang="en-US"/>
           </a:p>
@@ -3090,7 +3085,7 @@
 </file>
 
 <file path=ppt/slides/slide1.xml><?xml version="1.0" encoding="utf-8"?>
-<p:sld xmlns:a="http://schemas.openxmlformats.org/drawingml/2006/main" xmlns:p="http://schemas.openxmlformats.org/presentationml/2006/main" xmlns:r="http://schemas.openxmlformats.org/officeDocument/2006/relationships">
+<p:sld xmlns:a="http://schemas.openxmlformats.org/drawingml/2006/main" xmlns:r="http://schemas.openxmlformats.org/officeDocument/2006/relationships" xmlns:p="http://schemas.openxmlformats.org/presentationml/2006/main">
   <p:cSld>
     <p:spTree>
       <p:nvGrpSpPr>
@@ -3098,7 +3093,14 @@
         <p:cNvGrpSpPr/>
         <p:nvPr/>
       </p:nvGrpSpPr>
-      <p:grpSpPr/>
+      <p:grpSpPr>
+        <a:xfrm>
+          <a:off x="0" y="0"/>
+          <a:ext cx="0" cy="0"/>
+          <a:chOff x="0" y="0"/>
+          <a:chExt cx="0" cy="0"/>
+        </a:xfrm>
+      </p:grpSpPr>
       <p:sp>
         <p:nvSpPr>
           <p:cNvPr id="2" name="Rectangle 1"/>
@@ -3139,6 +3141,7 @@
           <a:lstStyle/>
           <a:p>
             <a:pPr algn="ctr"/>
+            <a:endParaRPr/>
           </a:p>
         </p:txBody>
       </p:sp>
@@ -3182,6 +3185,7 @@
           <a:lstStyle/>
           <a:p>
             <a:pPr algn="ctr"/>
+            <a:endParaRPr/>
           </a:p>
         </p:txBody>
       </p:sp>
@@ -3194,7 +3198,7 @@
         <p:spPr>
           <a:xfrm>
             <a:off x="914400" y="1371600"/>
-            <a:ext cx="10058400" cy="1371600"/>
+            <a:ext cx="10058400" cy="1200329"/>
           </a:xfrm>
           <a:prstGeom prst="rect">
             <a:avLst/>
@@ -3216,8 +3220,14 @@
               </a:defRPr>
             </a:pPr>
             <a:r>
+              <a:rPr lang="en-US" dirty="0"/>
+              <a:t>MP5 </a:t>
+            </a:r>
+            <a:r>
+              <a:rPr dirty="0" err="1"/>
               <a:t>MiniClaw</a:t>
             </a:r>
+            <a:endParaRPr dirty="0"/>
           </a:p>
         </p:txBody>
       </p:sp>
@@ -3324,7 +3334,16 @@
               </a:defRPr>
             </a:pPr>
             <a:r>
-              <a:t>ME 493B  |  RobotExpo 2026  |  ACME Robotics</a:t>
+              <a:rPr dirty="0"/>
+              <a:t>ME 493B  |  </a:t>
+            </a:r>
+            <a:r>
+              <a:rPr dirty="0" err="1"/>
+              <a:t>RobotExpo</a:t>
+            </a:r>
+            <a:r>
+              <a:rPr dirty="0"/>
+              <a:t> 2026  |  ACME Robotics</a:t>
             </a:r>
           </a:p>
         </p:txBody>
@@ -3338,7 +3357,7 @@
 </file>
 
 <file path=ppt/slides/slide10.xml><?xml version="1.0" encoding="utf-8"?>
-<p:sld xmlns:a="http://schemas.openxmlformats.org/drawingml/2006/main" xmlns:p="http://schemas.openxmlformats.org/presentationml/2006/main" xmlns:r="http://schemas.openxmlformats.org/officeDocument/2006/relationships">
+<p:sld xmlns:a="http://schemas.openxmlformats.org/drawingml/2006/main" xmlns:r="http://schemas.openxmlformats.org/officeDocument/2006/relationships" xmlns:p="http://schemas.openxmlformats.org/presentationml/2006/main">
   <p:cSld>
     <p:bg>
       <p:bgPr>
@@ -3354,7 +3373,14 @@
         <p:cNvGrpSpPr/>
         <p:nvPr/>
       </p:nvGrpSpPr>
-      <p:grpSpPr/>
+      <p:grpSpPr>
+        <a:xfrm>
+          <a:off x="0" y="0"/>
+          <a:ext cx="0" cy="0"/>
+          <a:chOff x="0" y="0"/>
+          <a:chExt cx="0" cy="0"/>
+        </a:xfrm>
+      </p:grpSpPr>
       <p:sp>
         <p:nvSpPr>
           <p:cNvPr id="2" name="Rectangle 1"/>
@@ -3395,6 +3421,7 @@
           <a:lstStyle/>
           <a:p>
             <a:pPr algn="ctr"/>
+            <a:endParaRPr/>
           </a:p>
         </p:txBody>
       </p:sp>
@@ -3474,6 +3501,7 @@
           <a:lstStyle/>
           <a:p>
             <a:pPr algn="ctr"/>
+            <a:endParaRPr/>
           </a:p>
         </p:txBody>
       </p:sp>
@@ -3589,6 +3617,7 @@
           <a:lstStyle/>
           <a:p>
             <a:pPr algn="ctr"/>
+            <a:endParaRPr/>
           </a:p>
         </p:txBody>
       </p:sp>
@@ -3673,7 +3702,7 @@
 </file>
 
 <file path=ppt/slides/slide11.xml><?xml version="1.0" encoding="utf-8"?>
-<p:sld xmlns:a="http://schemas.openxmlformats.org/drawingml/2006/main" xmlns:p="http://schemas.openxmlformats.org/presentationml/2006/main" xmlns:r="http://schemas.openxmlformats.org/officeDocument/2006/relationships">
+<p:sld xmlns:a="http://schemas.openxmlformats.org/drawingml/2006/main" xmlns:r="http://schemas.openxmlformats.org/officeDocument/2006/relationships" xmlns:p="http://schemas.openxmlformats.org/presentationml/2006/main">
   <p:cSld>
     <p:bg>
       <p:bgPr>
@@ -3689,7 +3718,14 @@
         <p:cNvGrpSpPr/>
         <p:nvPr/>
       </p:nvGrpSpPr>
-      <p:grpSpPr/>
+      <p:grpSpPr>
+        <a:xfrm>
+          <a:off x="0" y="0"/>
+          <a:ext cx="0" cy="0"/>
+          <a:chOff x="0" y="0"/>
+          <a:chExt cx="0" cy="0"/>
+        </a:xfrm>
+      </p:grpSpPr>
       <p:sp>
         <p:nvSpPr>
           <p:cNvPr id="2" name="Rectangle 1"/>
@@ -3730,6 +3766,7 @@
           <a:lstStyle/>
           <a:p>
             <a:pPr algn="ctr"/>
+            <a:endParaRPr/>
           </a:p>
         </p:txBody>
       </p:sp>
@@ -3875,6 +3912,7 @@
               </a:defRPr>
             </a:pPr>
             <a:r>
+              <a:rPr dirty="0"/>
               <a:t>Haben's four-bar linkage sweeping −50° to +50°</a:t>
             </a:r>
           </a:p>
@@ -3891,6 +3929,7 @@
               </a:defRPr>
             </a:pPr>
             <a:r>
+              <a:rPr dirty="0"/>
               <a:t>Jaw opening from 0 to 40 mm and back</a:t>
             </a:r>
           </a:p>
@@ -3907,6 +3946,7 @@
               </a:defRPr>
             </a:pPr>
             <a:r>
+              <a:rPr dirty="0"/>
               <a:t>Transmission angle staying in workable band</a:t>
             </a:r>
           </a:p>
@@ -3923,6 +3963,7 @@
               </a:defRPr>
             </a:pPr>
             <a:r>
+              <a:rPr dirty="0"/>
               <a:t>Real-time data display</a:t>
             </a:r>
           </a:p>
@@ -3959,6 +4000,7 @@
               </a:defRPr>
             </a:pPr>
             <a:r>
+              <a:rPr dirty="0"/>
               <a:t>Part 2: Live Tool Call</a:t>
             </a:r>
           </a:p>
@@ -3998,7 +4040,12 @@
               </a:defRPr>
             </a:pPr>
             <a:r>
-              <a:t>compute_transmission_angle(L3=32)</a:t>
+              <a:rPr dirty="0" err="1"/>
+              <a:t>compute_transmission_angle</a:t>
+            </a:r>
+            <a:r>
+              <a:rPr dirty="0"/>
+              <a:t>(L3=32)</a:t>
             </a:r>
           </a:p>
           <a:p>
@@ -4014,6 +4061,7 @@
               </a:defRPr>
             </a:pPr>
             <a:r>
+              <a:rPr dirty="0"/>
               <a:t>vs. our design (L3=29)</a:t>
             </a:r>
           </a:p>
@@ -4030,6 +4078,7 @@
               </a:defRPr>
             </a:pPr>
             <a:r>
+              <a:rPr dirty="0"/>
               <a:t>Shows angle drops with 3 mm change</a:t>
             </a:r>
           </a:p>
@@ -4046,6 +4095,7 @@
               </a:defRPr>
             </a:pPr>
             <a:r>
+              <a:rPr dirty="0"/>
               <a:t>Tool catches bad geometry instantly</a:t>
             </a:r>
           </a:p>
@@ -4091,6 +4141,7 @@
           <a:lstStyle/>
           <a:p>
             <a:pPr algn="ctr"/>
+            <a:endParaRPr/>
           </a:p>
         </p:txBody>
       </p:sp>
@@ -4161,37 +4212,65 @@
               </a:defRPr>
             </a:pPr>
             <a:r>
+              <a:rPr dirty="0"/>
               <a:t>$ python3 linkage_simulation.py</a:t>
             </a:r>
-            <a:br/>
-            <a:br/>
-            <a:r>
+            <a:br>
+              <a:rPr dirty="0"/>
+            </a:br>
+            <a:br>
+              <a:rPr dirty="0"/>
+            </a:br>
+            <a:r>
+              <a:rPr dirty="0"/>
               <a:t>$ python3 transmission_angle_check.py</a:t>
             </a:r>
-            <a:br/>
-            <a:br/>
-            <a:r>
+            <a:br>
+              <a:rPr dirty="0"/>
+            </a:br>
+            <a:br>
+              <a:rPr dirty="0"/>
+            </a:br>
+            <a:r>
+              <a:rPr dirty="0"/>
               <a:t>--- Haben's design ---</a:t>
             </a:r>
-            <a:br/>
-            <a:r>
+            <a:br>
+              <a:rPr dirty="0"/>
+            </a:br>
+            <a:r>
+              <a:rPr dirty="0"/>
               <a:t>  μ range:  61.3° – 91.3°</a:t>
             </a:r>
-            <a:br/>
-            <a:r>
+            <a:br>
+              <a:rPr dirty="0"/>
+            </a:br>
+            <a:r>
+              <a:rPr dirty="0"/>
               <a:t>  Margin:   21.3° above 40°</a:t>
             </a:r>
-            <a:br/>
-            <a:br/>
-            <a:r>
+            <a:br>
+              <a:rPr dirty="0"/>
+            </a:br>
+            <a:br>
+              <a:rPr dirty="0"/>
+            </a:br>
+            <a:r>
+              <a:rPr dirty="0"/>
               <a:t>--- Perturbed: L3=32 ---</a:t>
             </a:r>
-            <a:br/>
-            <a:r>
+            <a:br>
+              <a:rPr dirty="0"/>
+            </a:br>
+            <a:r>
+              <a:rPr dirty="0"/>
               <a:t>  μ range:  56.0° – 84.1°</a:t>
             </a:r>
-            <a:br/>
-            <a:r>
+            <a:br>
+              <a:rPr dirty="0"/>
+            </a:br>
+            <a:r>
+              <a:rPr dirty="0"/>
               <a:t>  Margin:   16.0° above 40°</a:t>
             </a:r>
           </a:p>
@@ -4206,7 +4285,7 @@
 </file>
 
 <file path=ppt/slides/slide12.xml><?xml version="1.0" encoding="utf-8"?>
-<p:sld xmlns:a="http://schemas.openxmlformats.org/drawingml/2006/main" xmlns:p="http://schemas.openxmlformats.org/presentationml/2006/main" xmlns:r="http://schemas.openxmlformats.org/officeDocument/2006/relationships">
+<p:sld xmlns:a="http://schemas.openxmlformats.org/drawingml/2006/main" xmlns:r="http://schemas.openxmlformats.org/officeDocument/2006/relationships" xmlns:p="http://schemas.openxmlformats.org/presentationml/2006/main">
   <p:cSld>
     <p:bg>
       <p:bgPr>
@@ -4222,7 +4301,14 @@
         <p:cNvGrpSpPr/>
         <p:nvPr/>
       </p:nvGrpSpPr>
-      <p:grpSpPr/>
+      <p:grpSpPr>
+        <a:xfrm>
+          <a:off x="0" y="0"/>
+          <a:ext cx="0" cy="0"/>
+          <a:chOff x="0" y="0"/>
+          <a:chExt cx="0" cy="0"/>
+        </a:xfrm>
+      </p:grpSpPr>
       <p:sp>
         <p:nvSpPr>
           <p:cNvPr id="2" name="Rectangle 1"/>
@@ -4263,6 +4349,7 @@
           <a:lstStyle/>
           <a:p>
             <a:pPr algn="ctr"/>
+            <a:endParaRPr/>
           </a:p>
         </p:txBody>
       </p:sp>
@@ -4321,8 +4408,20 @@
                 <a:tableStyleId>{5C22544A-7EE6-4342-B048-85BDC9FD1C3A}</a:tableStyleId>
               </a:tblPr>
               <a:tblGrid>
-                <a:gridCol w="3200400"/>
-                <a:gridCol w="2560320"/>
+                <a:gridCol w="3200400">
+                  <a:extLst>
+                    <a:ext uri="{9D8B030D-6E8A-4147-A177-3AD203B41FA5}">
+                      <a16:colId xmlns:a16="http://schemas.microsoft.com/office/drawing/2014/main" val="20000"/>
+                    </a:ext>
+                  </a:extLst>
+                </a:gridCol>
+                <a:gridCol w="2560320">
+                  <a:extLst>
+                    <a:ext uri="{9D8B030D-6E8A-4147-A177-3AD203B41FA5}">
+                      <a16:colId xmlns:a16="http://schemas.microsoft.com/office/drawing/2014/main" val="20001"/>
+                    </a:ext>
+                  </a:extLst>
+                </a:gridCol>
               </a:tblGrid>
               <a:tr h="609600">
                 <a:tc>
@@ -4373,6 +4472,11 @@
                     </a:solidFill>
                   </a:tcPr>
                 </a:tc>
+                <a:extLst>
+                  <a:ext uri="{0D108BD9-81ED-4DB2-BD59-A6C34878D82A}">
+                    <a16:rowId xmlns:a16="http://schemas.microsoft.com/office/drawing/2014/main" val="10000"/>
+                  </a:ext>
+                </a:extLst>
               </a:tr>
               <a:tr h="609600">
                 <a:tc>
@@ -4415,6 +4519,11 @@
                   </a:txBody>
                   <a:tcPr/>
                 </a:tc>
+                <a:extLst>
+                  <a:ext uri="{0D108BD9-81ED-4DB2-BD59-A6C34878D82A}">
+                    <a16:rowId xmlns:a16="http://schemas.microsoft.com/office/drawing/2014/main" val="10001"/>
+                  </a:ext>
+                </a:extLst>
               </a:tr>
               <a:tr h="609600">
                 <a:tc>
@@ -4465,6 +4574,11 @@
                     </a:solidFill>
                   </a:tcPr>
                 </a:tc>
+                <a:extLst>
+                  <a:ext uri="{0D108BD9-81ED-4DB2-BD59-A6C34878D82A}">
+                    <a16:rowId xmlns:a16="http://schemas.microsoft.com/office/drawing/2014/main" val="10002"/>
+                  </a:ext>
+                </a:extLst>
               </a:tr>
               <a:tr h="609600">
                 <a:tc>
@@ -4507,6 +4621,11 @@
                   </a:txBody>
                   <a:tcPr/>
                 </a:tc>
+                <a:extLst>
+                  <a:ext uri="{0D108BD9-81ED-4DB2-BD59-A6C34878D82A}">
+                    <a16:rowId xmlns:a16="http://schemas.microsoft.com/office/drawing/2014/main" val="10003"/>
+                  </a:ext>
+                </a:extLst>
               </a:tr>
               <a:tr h="609600">
                 <a:tc>
@@ -4557,6 +4676,11 @@
                     </a:solidFill>
                   </a:tcPr>
                 </a:tc>
+                <a:extLst>
+                  <a:ext uri="{0D108BD9-81ED-4DB2-BD59-A6C34878D82A}">
+                    <a16:rowId xmlns:a16="http://schemas.microsoft.com/office/drawing/2014/main" val="10004"/>
+                  </a:ext>
+                </a:extLst>
               </a:tr>
               <a:tr h="609600">
                 <a:tc>
@@ -4599,6 +4723,11 @@
                   </a:txBody>
                   <a:tcPr/>
                 </a:tc>
+                <a:extLst>
+                  <a:ext uri="{0D108BD9-81ED-4DB2-BD59-A6C34878D82A}">
+                    <a16:rowId xmlns:a16="http://schemas.microsoft.com/office/drawing/2014/main" val="10005"/>
+                  </a:ext>
+                </a:extLst>
               </a:tr>
             </a:tbl>
           </a:graphicData>
@@ -4649,7 +4778,7 @@
 </file>
 
 <file path=ppt/slides/slide2.xml><?xml version="1.0" encoding="utf-8"?>
-<p:sld xmlns:a="http://schemas.openxmlformats.org/drawingml/2006/main" xmlns:p="http://schemas.openxmlformats.org/presentationml/2006/main" xmlns:r="http://schemas.openxmlformats.org/officeDocument/2006/relationships">
+<p:sld xmlns:a="http://schemas.openxmlformats.org/drawingml/2006/main" xmlns:r="http://schemas.openxmlformats.org/officeDocument/2006/relationships" xmlns:p="http://schemas.openxmlformats.org/presentationml/2006/main">
   <p:cSld>
     <p:bg>
       <p:bgPr>
@@ -4665,7 +4794,14 @@
         <p:cNvGrpSpPr/>
         <p:nvPr/>
       </p:nvGrpSpPr>
-      <p:grpSpPr/>
+      <p:grpSpPr>
+        <a:xfrm>
+          <a:off x="0" y="0"/>
+          <a:ext cx="0" cy="0"/>
+          <a:chOff x="0" y="0"/>
+          <a:chExt cx="0" cy="0"/>
+        </a:xfrm>
+      </p:grpSpPr>
       <p:sp>
         <p:nvSpPr>
           <p:cNvPr id="2" name="Rectangle 1"/>
@@ -4706,6 +4842,7 @@
           <a:lstStyle/>
           <a:p>
             <a:pPr algn="ctr"/>
+            <a:endParaRPr/>
           </a:p>
         </p:txBody>
       </p:sp>
@@ -4776,6 +4913,7 @@
               </a:defRPr>
             </a:pPr>
             <a:r>
+              <a:rPr dirty="0"/>
               <a:t>What Jordan asked us to build</a:t>
             </a:r>
           </a:p>
@@ -4789,8 +4927,8 @@
         </p:nvSpPr>
         <p:spPr>
           <a:xfrm>
-            <a:off x="731520" y="1554480"/>
-            <a:ext cx="5029200" cy="457200"/>
+            <a:off x="364067" y="1554480"/>
+            <a:ext cx="5427133" cy="492443"/>
           </a:xfrm>
           <a:prstGeom prst="rect">
             <a:avLst/>
@@ -4812,6 +4950,7 @@
               </a:defRPr>
             </a:pPr>
             <a:r>
+              <a:rPr dirty="0"/>
               <a:t>Jordan Chen Design Brief — MP1</a:t>
             </a:r>
           </a:p>
@@ -4825,8 +4964,8 @@
         </p:nvSpPr>
         <p:spPr>
           <a:xfrm>
-            <a:off x="914400" y="2194560"/>
-            <a:ext cx="5029200" cy="4114800"/>
+            <a:off x="364067" y="2186067"/>
+            <a:ext cx="5621867" cy="3857466"/>
           </a:xfrm>
           <a:prstGeom prst="rect">
             <a:avLst/>
@@ -4851,7 +4990,32 @@
               </a:defRPr>
             </a:pPr>
             <a:r>
-              <a:t>Compete with Hiwonder's BigClaw at RobotExpo 2026</a:t>
+              <a:rPr dirty="0"/>
+              <a:t>Compete with </a:t>
+            </a:r>
+            <a:r>
+              <a:rPr dirty="0" err="1"/>
+              <a:t>Hiwonder's</a:t>
+            </a:r>
+            <a:r>
+              <a:rPr dirty="0"/>
+              <a:t> </a:t>
+            </a:r>
+            <a:r>
+              <a:rPr dirty="0" err="1"/>
+              <a:t>BigClaw</a:t>
+            </a:r>
+            <a:r>
+              <a:rPr dirty="0"/>
+              <a:t> at </a:t>
+            </a:r>
+            <a:r>
+              <a:rPr dirty="0" err="1"/>
+              <a:t>RobotExpo</a:t>
+            </a:r>
+            <a:r>
+              <a:rPr dirty="0"/>
+              <a:t> 2026</a:t>
             </a:r>
           </a:p>
           <a:p>
@@ -4867,6 +5031,7 @@
               </a:defRPr>
             </a:pPr>
             <a:r>
+              <a:rPr dirty="0"/>
               <a:t>Envelope: 92 × 46 × 55 mm</a:t>
             </a:r>
           </a:p>
@@ -4883,6 +5048,7 @@
               </a:defRPr>
             </a:pPr>
             <a:r>
+              <a:rPr dirty="0"/>
               <a:t>Jaw opening: ≥ 40 mm</a:t>
             </a:r>
           </a:p>
@@ -4899,6 +5065,7 @@
               </a:defRPr>
             </a:pPr>
             <a:r>
+              <a:rPr dirty="0"/>
               <a:t>Thumb-wheel turns: 2–3 from open to closed</a:t>
             </a:r>
           </a:p>
@@ -4915,6 +5082,7 @@
               </a:defRPr>
             </a:pPr>
             <a:r>
+              <a:rPr dirty="0"/>
               <a:t>Grip force: 5–8 N</a:t>
             </a:r>
           </a:p>
@@ -4931,6 +5099,7 @@
               </a:defRPr>
             </a:pPr>
             <a:r>
+              <a:rPr dirty="0"/>
               <a:t>Material: FDM PLA (Prusa MK4S)</a:t>
             </a:r>
           </a:p>
@@ -4947,6 +5116,7 @@
               </a:defRPr>
             </a:pPr>
             <a:r>
+              <a:rPr dirty="0"/>
               <a:t>Part count: &lt; 15 parts</a:t>
             </a:r>
           </a:p>
@@ -4963,6 +5133,7 @@
               </a:defRPr>
             </a:pPr>
             <a:r>
+              <a:rPr dirty="0"/>
               <a:t>Cost: &lt; $3/unit at 500-unit scale</a:t>
             </a:r>
           </a:p>
@@ -5008,6 +5179,7 @@
           <a:lstStyle/>
           <a:p>
             <a:pPr algn="ctr"/>
+            <a:endParaRPr/>
           </a:p>
         </p:txBody>
       </p:sp>
@@ -5092,7 +5264,7 @@
 </file>
 
 <file path=ppt/slides/slide3.xml><?xml version="1.0" encoding="utf-8"?>
-<p:sld xmlns:a="http://schemas.openxmlformats.org/drawingml/2006/main" xmlns:p="http://schemas.openxmlformats.org/presentationml/2006/main" xmlns:r="http://schemas.openxmlformats.org/officeDocument/2006/relationships">
+<p:sld xmlns:a="http://schemas.openxmlformats.org/drawingml/2006/main" xmlns:r="http://schemas.openxmlformats.org/officeDocument/2006/relationships" xmlns:p="http://schemas.openxmlformats.org/presentationml/2006/main">
   <p:cSld>
     <p:bg>
       <p:bgPr>
@@ -5108,7 +5280,14 @@
         <p:cNvGrpSpPr/>
         <p:nvPr/>
       </p:nvGrpSpPr>
-      <p:grpSpPr/>
+      <p:grpSpPr>
+        <a:xfrm>
+          <a:off x="0" y="0"/>
+          <a:ext cx="0" cy="0"/>
+          <a:chOff x="0" y="0"/>
+          <a:chExt cx="0" cy="0"/>
+        </a:xfrm>
+      </p:grpSpPr>
       <p:sp>
         <p:nvSpPr>
           <p:cNvPr id="2" name="Rectangle 1"/>
@@ -5149,6 +5328,7 @@
           <a:lstStyle/>
           <a:p>
             <a:pPr algn="ctr"/>
+            <a:endParaRPr/>
           </a:p>
         </p:txBody>
       </p:sp>
@@ -5243,10 +5423,34 @@
                 <a:tableStyleId>{5C22544A-7EE6-4342-B048-85BDC9FD1C3A}</a:tableStyleId>
               </a:tblPr>
               <a:tblGrid>
-                <a:gridCol w="2926080"/>
-                <a:gridCol w="2560320"/>
-                <a:gridCol w="2560320"/>
-                <a:gridCol w="2468880"/>
+                <a:gridCol w="2926080">
+                  <a:extLst>
+                    <a:ext uri="{9D8B030D-6E8A-4147-A177-3AD203B41FA5}">
+                      <a16:colId xmlns:a16="http://schemas.microsoft.com/office/drawing/2014/main" val="20000"/>
+                    </a:ext>
+                  </a:extLst>
+                </a:gridCol>
+                <a:gridCol w="2560320">
+                  <a:extLst>
+                    <a:ext uri="{9D8B030D-6E8A-4147-A177-3AD203B41FA5}">
+                      <a16:colId xmlns:a16="http://schemas.microsoft.com/office/drawing/2014/main" val="20001"/>
+                    </a:ext>
+                  </a:extLst>
+                </a:gridCol>
+                <a:gridCol w="2560320">
+                  <a:extLst>
+                    <a:ext uri="{9D8B030D-6E8A-4147-A177-3AD203B41FA5}">
+                      <a16:colId xmlns:a16="http://schemas.microsoft.com/office/drawing/2014/main" val="20002"/>
+                    </a:ext>
+                  </a:extLst>
+                </a:gridCol>
+                <a:gridCol w="2468880">
+                  <a:extLst>
+                    <a:ext uri="{9D8B030D-6E8A-4147-A177-3AD203B41FA5}">
+                      <a16:colId xmlns:a16="http://schemas.microsoft.com/office/drawing/2014/main" val="20003"/>
+                    </a:ext>
+                  </a:extLst>
+                </a:gridCol>
               </a:tblGrid>
               <a:tr h="587828">
                 <a:tc>
@@ -5345,6 +5549,11 @@
                     </a:solidFill>
                   </a:tcPr>
                 </a:tc>
+                <a:extLst>
+                  <a:ext uri="{0D108BD9-81ED-4DB2-BD59-A6C34878D82A}">
+                    <a16:rowId xmlns:a16="http://schemas.microsoft.com/office/drawing/2014/main" val="10000"/>
+                  </a:ext>
+                </a:extLst>
               </a:tr>
               <a:tr h="587828">
                 <a:tc>
@@ -5427,6 +5636,11 @@
                   </a:txBody>
                   <a:tcPr/>
                 </a:tc>
+                <a:extLst>
+                  <a:ext uri="{0D108BD9-81ED-4DB2-BD59-A6C34878D82A}">
+                    <a16:rowId xmlns:a16="http://schemas.microsoft.com/office/drawing/2014/main" val="10001"/>
+                  </a:ext>
+                </a:extLst>
               </a:tr>
               <a:tr h="587828">
                 <a:tc>
@@ -5525,6 +5739,11 @@
                     </a:solidFill>
                   </a:tcPr>
                 </a:tc>
+                <a:extLst>
+                  <a:ext uri="{0D108BD9-81ED-4DB2-BD59-A6C34878D82A}">
+                    <a16:rowId xmlns:a16="http://schemas.microsoft.com/office/drawing/2014/main" val="10002"/>
+                  </a:ext>
+                </a:extLst>
               </a:tr>
               <a:tr h="587828">
                 <a:tc>
@@ -5607,6 +5826,11 @@
                   </a:txBody>
                   <a:tcPr/>
                 </a:tc>
+                <a:extLst>
+                  <a:ext uri="{0D108BD9-81ED-4DB2-BD59-A6C34878D82A}">
+                    <a16:rowId xmlns:a16="http://schemas.microsoft.com/office/drawing/2014/main" val="10003"/>
+                  </a:ext>
+                </a:extLst>
               </a:tr>
               <a:tr h="587828">
                 <a:tc>
@@ -5705,6 +5929,11 @@
                     </a:solidFill>
                   </a:tcPr>
                 </a:tc>
+                <a:extLst>
+                  <a:ext uri="{0D108BD9-81ED-4DB2-BD59-A6C34878D82A}">
+                    <a16:rowId xmlns:a16="http://schemas.microsoft.com/office/drawing/2014/main" val="10004"/>
+                  </a:ext>
+                </a:extLst>
               </a:tr>
               <a:tr h="587828">
                 <a:tc>
@@ -5787,6 +6016,11 @@
                   </a:txBody>
                   <a:tcPr/>
                 </a:tc>
+                <a:extLst>
+                  <a:ext uri="{0D108BD9-81ED-4DB2-BD59-A6C34878D82A}">
+                    <a16:rowId xmlns:a16="http://schemas.microsoft.com/office/drawing/2014/main" val="10005"/>
+                  </a:ext>
+                </a:extLst>
               </a:tr>
               <a:tr h="587832">
                 <a:tc>
@@ -5885,6 +6119,11 @@
                     </a:solidFill>
                   </a:tcPr>
                 </a:tc>
+                <a:extLst>
+                  <a:ext uri="{0D108BD9-81ED-4DB2-BD59-A6C34878D82A}">
+                    <a16:rowId xmlns:a16="http://schemas.microsoft.com/office/drawing/2014/main" val="10006"/>
+                  </a:ext>
+                </a:extLst>
               </a:tr>
             </a:tbl>
           </a:graphicData>
@@ -5899,7 +6138,7 @@
 </file>
 
 <file path=ppt/slides/slide4.xml><?xml version="1.0" encoding="utf-8"?>
-<p:sld xmlns:a="http://schemas.openxmlformats.org/drawingml/2006/main" xmlns:p="http://schemas.openxmlformats.org/presentationml/2006/main" xmlns:r="http://schemas.openxmlformats.org/officeDocument/2006/relationships">
+<p:sld xmlns:a="http://schemas.openxmlformats.org/drawingml/2006/main" xmlns:r="http://schemas.openxmlformats.org/officeDocument/2006/relationships" xmlns:p="http://schemas.openxmlformats.org/presentationml/2006/main">
   <p:cSld>
     <p:bg>
       <p:bgPr>
@@ -5915,7 +6154,14 @@
         <p:cNvGrpSpPr/>
         <p:nvPr/>
       </p:nvGrpSpPr>
-      <p:grpSpPr/>
+      <p:grpSpPr>
+        <a:xfrm>
+          <a:off x="0" y="0"/>
+          <a:ext cx="0" cy="0"/>
+          <a:chOff x="0" y="0"/>
+          <a:chExt cx="0" cy="0"/>
+        </a:xfrm>
+      </p:grpSpPr>
       <p:sp>
         <p:nvSpPr>
           <p:cNvPr id="2" name="Rectangle 1"/>
@@ -5956,6 +6202,7 @@
           <a:lstStyle/>
           <a:p>
             <a:pPr algn="ctr"/>
+            <a:endParaRPr/>
           </a:p>
         </p:txBody>
       </p:sp>
@@ -6057,7 +6304,7 @@
         <p:spPr>
           <a:xfrm>
             <a:off x="731520" y="1554480"/>
-            <a:ext cx="5029200" cy="457200"/>
+            <a:ext cx="5669280" cy="457200"/>
           </a:xfrm>
           <a:prstGeom prst="rect">
             <a:avLst/>
@@ -6079,6 +6326,7 @@
               </a:defRPr>
             </a:pPr>
             <a:r>
+              <a:rPr dirty="0"/>
               <a:t>Why we accepted 0.28 turns instead of 2–3</a:t>
             </a:r>
           </a:p>
@@ -6124,6 +6372,7 @@
           <a:lstStyle/>
           <a:p>
             <a:pPr algn="ctr"/>
+            <a:endParaRPr/>
           </a:p>
         </p:txBody>
       </p:sp>
@@ -6306,6 +6555,7 @@
           <a:lstStyle/>
           <a:p>
             <a:pPr algn="ctr"/>
+            <a:endParaRPr/>
           </a:p>
         </p:txBody>
       </p:sp>
@@ -6457,7 +6707,7 @@
 </file>
 
 <file path=ppt/slides/slide5.xml><?xml version="1.0" encoding="utf-8"?>
-<p:sld xmlns:a="http://schemas.openxmlformats.org/drawingml/2006/main" xmlns:p="http://schemas.openxmlformats.org/presentationml/2006/main" xmlns:r="http://schemas.openxmlformats.org/officeDocument/2006/relationships">
+<p:sld xmlns:a="http://schemas.openxmlformats.org/drawingml/2006/main" xmlns:r="http://schemas.openxmlformats.org/officeDocument/2006/relationships" xmlns:p="http://schemas.openxmlformats.org/presentationml/2006/main">
   <p:cSld>
     <p:bg>
       <p:bgPr>
@@ -6473,7 +6723,14 @@
         <p:cNvGrpSpPr/>
         <p:nvPr/>
       </p:nvGrpSpPr>
-      <p:grpSpPr/>
+      <p:grpSpPr>
+        <a:xfrm>
+          <a:off x="0" y="0"/>
+          <a:ext cx="0" cy="0"/>
+          <a:chOff x="0" y="0"/>
+          <a:chExt cx="0" cy="0"/>
+        </a:xfrm>
+      </p:grpSpPr>
       <p:sp>
         <p:nvSpPr>
           <p:cNvPr id="2" name="Rectangle 1"/>
@@ -6514,6 +6771,7 @@
           <a:lstStyle/>
           <a:p>
             <a:pPr algn="ctr"/>
+            <a:endParaRPr/>
           </a:p>
         </p:txBody>
       </p:sp>
@@ -6637,6 +6895,7 @@
               </a:defRPr>
             </a:pPr>
             <a:r>
+              <a:rPr dirty="0"/>
               <a:t>One document upload corrected the entire design basis</a:t>
             </a:r>
           </a:p>
@@ -6661,9 +6920,27 @@
                 <a:tableStyleId>{5C22544A-7EE6-4342-B048-85BDC9FD1C3A}</a:tableStyleId>
               </a:tblPr>
               <a:tblGrid>
-                <a:gridCol w="2103120"/>
-                <a:gridCol w="2103120"/>
-                <a:gridCol w="2194560"/>
+                <a:gridCol w="2103120">
+                  <a:extLst>
+                    <a:ext uri="{9D8B030D-6E8A-4147-A177-3AD203B41FA5}">
+                      <a16:colId xmlns:a16="http://schemas.microsoft.com/office/drawing/2014/main" val="20000"/>
+                    </a:ext>
+                  </a:extLst>
+                </a:gridCol>
+                <a:gridCol w="2103120">
+                  <a:extLst>
+                    <a:ext uri="{9D8B030D-6E8A-4147-A177-3AD203B41FA5}">
+                      <a16:colId xmlns:a16="http://schemas.microsoft.com/office/drawing/2014/main" val="20001"/>
+                    </a:ext>
+                  </a:extLst>
+                </a:gridCol>
+                <a:gridCol w="2194560">
+                  <a:extLst>
+                    <a:ext uri="{9D8B030D-6E8A-4147-A177-3AD203B41FA5}">
+                      <a16:colId xmlns:a16="http://schemas.microsoft.com/office/drawing/2014/main" val="20002"/>
+                    </a:ext>
+                  </a:extLst>
+                </a:gridCol>
               </a:tblGrid>
               <a:tr h="585216">
                 <a:tc>
@@ -6738,6 +7015,11 @@
                     </a:solidFill>
                   </a:tcPr>
                 </a:tc>
+                <a:extLst>
+                  <a:ext uri="{0D108BD9-81ED-4DB2-BD59-A6C34878D82A}">
+                    <a16:rowId xmlns:a16="http://schemas.microsoft.com/office/drawing/2014/main" val="10000"/>
+                  </a:ext>
+                </a:extLst>
               </a:tr>
               <a:tr h="585216">
                 <a:tc>
@@ -6800,6 +7082,11 @@
                   </a:txBody>
                   <a:tcPr/>
                 </a:tc>
+                <a:extLst>
+                  <a:ext uri="{0D108BD9-81ED-4DB2-BD59-A6C34878D82A}">
+                    <a16:rowId xmlns:a16="http://schemas.microsoft.com/office/drawing/2014/main" val="10001"/>
+                  </a:ext>
+                </a:extLst>
               </a:tr>
               <a:tr h="585216">
                 <a:tc>
@@ -6874,6 +7161,11 @@
                     </a:solidFill>
                   </a:tcPr>
                 </a:tc>
+                <a:extLst>
+                  <a:ext uri="{0D108BD9-81ED-4DB2-BD59-A6C34878D82A}">
+                    <a16:rowId xmlns:a16="http://schemas.microsoft.com/office/drawing/2014/main" val="10002"/>
+                  </a:ext>
+                </a:extLst>
               </a:tr>
               <a:tr h="585216">
                 <a:tc>
@@ -6936,6 +7228,11 @@
                   </a:txBody>
                   <a:tcPr/>
                 </a:tc>
+                <a:extLst>
+                  <a:ext uri="{0D108BD9-81ED-4DB2-BD59-A6C34878D82A}">
+                    <a16:rowId xmlns:a16="http://schemas.microsoft.com/office/drawing/2014/main" val="10003"/>
+                  </a:ext>
+                </a:extLst>
               </a:tr>
               <a:tr h="585216">
                 <a:tc>
@@ -7010,6 +7307,11 @@
                     </a:solidFill>
                   </a:tcPr>
                 </a:tc>
+                <a:extLst>
+                  <a:ext uri="{0D108BD9-81ED-4DB2-BD59-A6C34878D82A}">
+                    <a16:rowId xmlns:a16="http://schemas.microsoft.com/office/drawing/2014/main" val="10004"/>
+                  </a:ext>
+                </a:extLst>
               </a:tr>
             </a:tbl>
           </a:graphicData>
@@ -7055,6 +7357,7 @@
           <a:lstStyle/>
           <a:p>
             <a:pPr algn="ctr"/>
+            <a:endParaRPr/>
           </a:p>
         </p:txBody>
       </p:sp>
@@ -7175,7 +7478,7 @@
 </file>
 
 <file path=ppt/slides/slide6.xml><?xml version="1.0" encoding="utf-8"?>
-<p:sld xmlns:a="http://schemas.openxmlformats.org/drawingml/2006/main" xmlns:p="http://schemas.openxmlformats.org/presentationml/2006/main" xmlns:r="http://schemas.openxmlformats.org/officeDocument/2006/relationships">
+<p:sld xmlns:a="http://schemas.openxmlformats.org/drawingml/2006/main" xmlns:r="http://schemas.openxmlformats.org/officeDocument/2006/relationships" xmlns:p="http://schemas.openxmlformats.org/presentationml/2006/main">
   <p:cSld>
     <p:bg>
       <p:bgPr>
@@ -7191,7 +7494,14 @@
         <p:cNvGrpSpPr/>
         <p:nvPr/>
       </p:nvGrpSpPr>
-      <p:grpSpPr/>
+      <p:grpSpPr>
+        <a:xfrm>
+          <a:off x="0" y="0"/>
+          <a:ext cx="0" cy="0"/>
+          <a:chOff x="0" y="0"/>
+          <a:chExt cx="0" cy="0"/>
+        </a:xfrm>
+      </p:grpSpPr>
       <p:sp>
         <p:nvSpPr>
           <p:cNvPr id="2" name="Rectangle 1"/>
@@ -7232,6 +7542,7 @@
           <a:lstStyle/>
           <a:p>
             <a:pPr algn="ctr"/>
+            <a:endParaRPr/>
           </a:p>
         </p:txBody>
       </p:sp>
@@ -7343,8 +7654,20 @@
                 <a:tableStyleId>{5C22544A-7EE6-4342-B048-85BDC9FD1C3A}</a:tableStyleId>
               </a:tblPr>
               <a:tblGrid>
-                <a:gridCol w="3200400"/>
-                <a:gridCol w="7315200"/>
+                <a:gridCol w="3200400">
+                  <a:extLst>
+                    <a:ext uri="{9D8B030D-6E8A-4147-A177-3AD203B41FA5}">
+                      <a16:colId xmlns:a16="http://schemas.microsoft.com/office/drawing/2014/main" val="20000"/>
+                    </a:ext>
+                  </a:extLst>
+                </a:gridCol>
+                <a:gridCol w="7315200">
+                  <a:extLst>
+                    <a:ext uri="{9D8B030D-6E8A-4147-A177-3AD203B41FA5}">
+                      <a16:colId xmlns:a16="http://schemas.microsoft.com/office/drawing/2014/main" val="20001"/>
+                    </a:ext>
+                  </a:extLst>
+                </a:gridCol>
               </a:tblGrid>
               <a:tr h="579120">
                 <a:tc>
@@ -7395,6 +7718,11 @@
                     </a:solidFill>
                   </a:tcPr>
                 </a:tc>
+                <a:extLst>
+                  <a:ext uri="{0D108BD9-81ED-4DB2-BD59-A6C34878D82A}">
+                    <a16:rowId xmlns:a16="http://schemas.microsoft.com/office/drawing/2014/main" val="10000"/>
+                  </a:ext>
+                </a:extLst>
               </a:tr>
               <a:tr h="579120">
                 <a:tc>
@@ -7437,6 +7765,11 @@
                   </a:txBody>
                   <a:tcPr/>
                 </a:tc>
+                <a:extLst>
+                  <a:ext uri="{0D108BD9-81ED-4DB2-BD59-A6C34878D82A}">
+                    <a16:rowId xmlns:a16="http://schemas.microsoft.com/office/drawing/2014/main" val="10001"/>
+                  </a:ext>
+                </a:extLst>
               </a:tr>
               <a:tr h="579120">
                 <a:tc>
@@ -7487,6 +7820,11 @@
                     </a:solidFill>
                   </a:tcPr>
                 </a:tc>
+                <a:extLst>
+                  <a:ext uri="{0D108BD9-81ED-4DB2-BD59-A6C34878D82A}">
+                    <a16:rowId xmlns:a16="http://schemas.microsoft.com/office/drawing/2014/main" val="10002"/>
+                  </a:ext>
+                </a:extLst>
               </a:tr>
               <a:tr h="579120">
                 <a:tc>
@@ -7529,6 +7867,11 @@
                   </a:txBody>
                   <a:tcPr/>
                 </a:tc>
+                <a:extLst>
+                  <a:ext uri="{0D108BD9-81ED-4DB2-BD59-A6C34878D82A}">
+                    <a16:rowId xmlns:a16="http://schemas.microsoft.com/office/drawing/2014/main" val="10003"/>
+                  </a:ext>
+                </a:extLst>
               </a:tr>
               <a:tr h="579120">
                 <a:tc>
@@ -7579,6 +7922,11 @@
                     </a:solidFill>
                   </a:tcPr>
                 </a:tc>
+                <a:extLst>
+                  <a:ext uri="{0D108BD9-81ED-4DB2-BD59-A6C34878D82A}">
+                    <a16:rowId xmlns:a16="http://schemas.microsoft.com/office/drawing/2014/main" val="10004"/>
+                  </a:ext>
+                </a:extLst>
               </a:tr>
               <a:tr h="579120">
                 <a:tc>
@@ -7621,6 +7969,11 @@
                   </a:txBody>
                   <a:tcPr/>
                 </a:tc>
+                <a:extLst>
+                  <a:ext uri="{0D108BD9-81ED-4DB2-BD59-A6C34878D82A}">
+                    <a16:rowId xmlns:a16="http://schemas.microsoft.com/office/drawing/2014/main" val="10005"/>
+                  </a:ext>
+                </a:extLst>
               </a:tr>
             </a:tbl>
           </a:graphicData>
@@ -7666,6 +8019,7 @@
           <a:lstStyle/>
           <a:p>
             <a:pPr algn="ctr"/>
+            <a:endParaRPr/>
           </a:p>
         </p:txBody>
       </p:sp>
@@ -7700,7 +8054,16 @@
               </a:defRPr>
             </a:pPr>
             <a:r>
-              <a:t>Live demo coming up: animated four-bar simulation + compute_transmission_angle() on perturbed geometry</a:t>
+              <a:rPr dirty="0"/>
+              <a:t>Live demo coming up: animated four-bar simulation + </a:t>
+            </a:r>
+            <a:r>
+              <a:rPr dirty="0" err="1"/>
+              <a:t>compute_transmission_angle</a:t>
+            </a:r>
+            <a:r>
+              <a:rPr dirty="0"/>
+              <a:t>() on perturbed geometry</a:t>
             </a:r>
           </a:p>
         </p:txBody>
@@ -7714,7 +8077,7 @@
 </file>
 
 <file path=ppt/slides/slide7.xml><?xml version="1.0" encoding="utf-8"?>
-<p:sld xmlns:a="http://schemas.openxmlformats.org/drawingml/2006/main" xmlns:p="http://schemas.openxmlformats.org/presentationml/2006/main" xmlns:r="http://schemas.openxmlformats.org/officeDocument/2006/relationships">
+<p:sld xmlns:a="http://schemas.openxmlformats.org/drawingml/2006/main" xmlns:r="http://schemas.openxmlformats.org/officeDocument/2006/relationships" xmlns:p="http://schemas.openxmlformats.org/presentationml/2006/main">
   <p:cSld>
     <p:bg>
       <p:bgPr>
@@ -7730,7 +8093,14 @@
         <p:cNvGrpSpPr/>
         <p:nvPr/>
       </p:nvGrpSpPr>
-      <p:grpSpPr/>
+      <p:grpSpPr>
+        <a:xfrm>
+          <a:off x="0" y="0"/>
+          <a:ext cx="0" cy="0"/>
+          <a:chOff x="0" y="0"/>
+          <a:chExt cx="0" cy="0"/>
+        </a:xfrm>
+      </p:grpSpPr>
       <p:sp>
         <p:nvSpPr>
           <p:cNvPr id="2" name="Rectangle 1"/>
@@ -7771,6 +8141,7 @@
           <a:lstStyle/>
           <a:p>
             <a:pPr algn="ctr"/>
+            <a:endParaRPr/>
           </a:p>
         </p:txBody>
       </p:sp>
@@ -7954,11 +8325,41 @@
                 <a:tableStyleId>{5C22544A-7EE6-4342-B048-85BDC9FD1C3A}</a:tableStyleId>
               </a:tblPr>
               <a:tblGrid>
-                <a:gridCol w="1828800"/>
-                <a:gridCol w="2103120"/>
-                <a:gridCol w="2103120"/>
-                <a:gridCol w="2103120"/>
-                <a:gridCol w="2377440"/>
+                <a:gridCol w="1828800">
+                  <a:extLst>
+                    <a:ext uri="{9D8B030D-6E8A-4147-A177-3AD203B41FA5}">
+                      <a16:colId xmlns:a16="http://schemas.microsoft.com/office/drawing/2014/main" val="20000"/>
+                    </a:ext>
+                  </a:extLst>
+                </a:gridCol>
+                <a:gridCol w="2103120">
+                  <a:extLst>
+                    <a:ext uri="{9D8B030D-6E8A-4147-A177-3AD203B41FA5}">
+                      <a16:colId xmlns:a16="http://schemas.microsoft.com/office/drawing/2014/main" val="20001"/>
+                    </a:ext>
+                  </a:extLst>
+                </a:gridCol>
+                <a:gridCol w="2103120">
+                  <a:extLst>
+                    <a:ext uri="{9D8B030D-6E8A-4147-A177-3AD203B41FA5}">
+                      <a16:colId xmlns:a16="http://schemas.microsoft.com/office/drawing/2014/main" val="20002"/>
+                    </a:ext>
+                  </a:extLst>
+                </a:gridCol>
+                <a:gridCol w="2103120">
+                  <a:extLst>
+                    <a:ext uri="{9D8B030D-6E8A-4147-A177-3AD203B41FA5}">
+                      <a16:colId xmlns:a16="http://schemas.microsoft.com/office/drawing/2014/main" val="20003"/>
+                    </a:ext>
+                  </a:extLst>
+                </a:gridCol>
+                <a:gridCol w="2377440">
+                  <a:extLst>
+                    <a:ext uri="{9D8B030D-6E8A-4147-A177-3AD203B41FA5}">
+                      <a16:colId xmlns:a16="http://schemas.microsoft.com/office/drawing/2014/main" val="20004"/>
+                    </a:ext>
+                  </a:extLst>
+                </a:gridCol>
               </a:tblGrid>
               <a:tr h="571500">
                 <a:tc>
@@ -8081,6 +8482,11 @@
                     </a:solidFill>
                   </a:tcPr>
                 </a:tc>
+                <a:extLst>
+                  <a:ext uri="{0D108BD9-81ED-4DB2-BD59-A6C34878D82A}">
+                    <a16:rowId xmlns:a16="http://schemas.microsoft.com/office/drawing/2014/main" val="10000"/>
+                  </a:ext>
+                </a:extLst>
               </a:tr>
               <a:tr h="571500">
                 <a:tc>
@@ -8183,6 +8589,11 @@
                   </a:txBody>
                   <a:tcPr/>
                 </a:tc>
+                <a:extLst>
+                  <a:ext uri="{0D108BD9-81ED-4DB2-BD59-A6C34878D82A}">
+                    <a16:rowId xmlns:a16="http://schemas.microsoft.com/office/drawing/2014/main" val="10001"/>
+                  </a:ext>
+                </a:extLst>
               </a:tr>
               <a:tr h="571500">
                 <a:tc>
@@ -8305,6 +8716,11 @@
                     </a:solidFill>
                   </a:tcPr>
                 </a:tc>
+                <a:extLst>
+                  <a:ext uri="{0D108BD9-81ED-4DB2-BD59-A6C34878D82A}">
+                    <a16:rowId xmlns:a16="http://schemas.microsoft.com/office/drawing/2014/main" val="10002"/>
+                  </a:ext>
+                </a:extLst>
               </a:tr>
               <a:tr h="571500">
                 <a:tc>
@@ -8407,6 +8823,11 @@
                   </a:txBody>
                   <a:tcPr/>
                 </a:tc>
+                <a:extLst>
+                  <a:ext uri="{0D108BD9-81ED-4DB2-BD59-A6C34878D82A}">
+                    <a16:rowId xmlns:a16="http://schemas.microsoft.com/office/drawing/2014/main" val="10003"/>
+                  </a:ext>
+                </a:extLst>
               </a:tr>
             </a:tbl>
           </a:graphicData>
@@ -8452,6 +8873,7 @@
           <a:lstStyle/>
           <a:p>
             <a:pPr algn="ctr"/>
+            <a:endParaRPr/>
           </a:p>
         </p:txBody>
       </p:sp>
@@ -8535,6 +8957,7 @@
           <a:lstStyle/>
           <a:p>
             <a:pPr algn="ctr"/>
+            <a:endParaRPr/>
           </a:p>
         </p:txBody>
       </p:sp>
@@ -8587,7 +9010,7 @@
 </file>
 
 <file path=ppt/slides/slide8.xml><?xml version="1.0" encoding="utf-8"?>
-<p:sld xmlns:a="http://schemas.openxmlformats.org/drawingml/2006/main" xmlns:p="http://schemas.openxmlformats.org/presentationml/2006/main" xmlns:r="http://schemas.openxmlformats.org/officeDocument/2006/relationships">
+<p:sld xmlns:a="http://schemas.openxmlformats.org/drawingml/2006/main" xmlns:r="http://schemas.openxmlformats.org/officeDocument/2006/relationships" xmlns:p="http://schemas.openxmlformats.org/presentationml/2006/main">
   <p:cSld>
     <p:bg>
       <p:bgPr>
@@ -8603,7 +9026,14 @@
         <p:cNvGrpSpPr/>
         <p:nvPr/>
       </p:nvGrpSpPr>
-      <p:grpSpPr/>
+      <p:grpSpPr>
+        <a:xfrm>
+          <a:off x="0" y="0"/>
+          <a:ext cx="0" cy="0"/>
+          <a:chOff x="0" y="0"/>
+          <a:chExt cx="0" cy="0"/>
+        </a:xfrm>
+      </p:grpSpPr>
       <p:sp>
         <p:nvSpPr>
           <p:cNvPr id="2" name="Rectangle 1"/>
@@ -8644,6 +9074,7 @@
           <a:lstStyle/>
           <a:p>
             <a:pPr algn="ctr"/>
+            <a:endParaRPr/>
           </a:p>
         </p:txBody>
       </p:sp>
@@ -8776,6 +9207,7 @@
           <a:lstStyle/>
           <a:p>
             <a:pPr algn="ctr"/>
+            <a:endParaRPr/>
           </a:p>
         </p:txBody>
       </p:sp>
@@ -8914,6 +9346,7 @@
           <a:lstStyle/>
           <a:p>
             <a:pPr algn="ctr"/>
+            <a:endParaRPr/>
           </a:p>
         </p:txBody>
       </p:sp>
@@ -9047,6 +9480,7 @@
           <a:lstStyle/>
           <a:p>
             <a:pPr algn="ctr"/>
+            <a:endParaRPr/>
           </a:p>
         </p:txBody>
       </p:sp>
@@ -9177,6 +9611,7 @@
           <a:lstStyle/>
           <a:p>
             <a:pPr algn="ctr"/>
+            <a:endParaRPr/>
           </a:p>
         </p:txBody>
       </p:sp>
@@ -9188,8 +9623,8 @@
         </p:nvSpPr>
         <p:spPr>
           <a:xfrm>
-            <a:off x="640080" y="6144768"/>
-            <a:ext cx="10972800" cy="457200"/>
+            <a:off x="423333" y="6144768"/>
+            <a:ext cx="11314853" cy="369332"/>
           </a:xfrm>
           <a:prstGeom prst="rect">
             <a:avLst/>
@@ -9211,6 +9646,7 @@
               </a:defRPr>
             </a:pPr>
             <a:r>
+              <a:rPr dirty="0"/>
               <a:t>Context management isn't optional — it's the difference between a correct design and a plausible-looking wrong one.</a:t>
             </a:r>
           </a:p>
@@ -9225,7 +9661,7 @@
 </file>
 
 <file path=ppt/slides/slide9.xml><?xml version="1.0" encoding="utf-8"?>
-<p:sld xmlns:a="http://schemas.openxmlformats.org/drawingml/2006/main" xmlns:p="http://schemas.openxmlformats.org/presentationml/2006/main" xmlns:r="http://schemas.openxmlformats.org/officeDocument/2006/relationships">
+<p:sld xmlns:a="http://schemas.openxmlformats.org/drawingml/2006/main" xmlns:r="http://schemas.openxmlformats.org/officeDocument/2006/relationships" xmlns:p="http://schemas.openxmlformats.org/presentationml/2006/main">
   <p:cSld>
     <p:bg>
       <p:bgPr>
@@ -9241,7 +9677,14 @@
         <p:cNvGrpSpPr/>
         <p:nvPr/>
       </p:nvGrpSpPr>
-      <p:grpSpPr/>
+      <p:grpSpPr>
+        <a:xfrm>
+          <a:off x="0" y="0"/>
+          <a:ext cx="0" cy="0"/>
+          <a:chOff x="0" y="0"/>
+          <a:chExt cx="0" cy="0"/>
+        </a:xfrm>
+      </p:grpSpPr>
       <p:sp>
         <p:nvSpPr>
           <p:cNvPr id="2" name="Rectangle 1"/>
@@ -9282,6 +9725,7 @@
           <a:lstStyle/>
           <a:p>
             <a:pPr algn="ctr"/>
+            <a:endParaRPr/>
           </a:p>
         </p:txBody>
       </p:sp>
@@ -9393,10 +9837,34 @@
                 <a:tableStyleId>{5C22544A-7EE6-4342-B048-85BDC9FD1C3A}</a:tableStyleId>
               </a:tblPr>
               <a:tblGrid>
-                <a:gridCol w="2103120"/>
-                <a:gridCol w="1828800"/>
-                <a:gridCol w="2286000"/>
-                <a:gridCol w="5029200"/>
+                <a:gridCol w="2103120">
+                  <a:extLst>
+                    <a:ext uri="{9D8B030D-6E8A-4147-A177-3AD203B41FA5}">
+                      <a16:colId xmlns:a16="http://schemas.microsoft.com/office/drawing/2014/main" val="20000"/>
+                    </a:ext>
+                  </a:extLst>
+                </a:gridCol>
+                <a:gridCol w="1828800">
+                  <a:extLst>
+                    <a:ext uri="{9D8B030D-6E8A-4147-A177-3AD203B41FA5}">
+                      <a16:colId xmlns:a16="http://schemas.microsoft.com/office/drawing/2014/main" val="20001"/>
+                    </a:ext>
+                  </a:extLst>
+                </a:gridCol>
+                <a:gridCol w="2286000">
+                  <a:extLst>
+                    <a:ext uri="{9D8B030D-6E8A-4147-A177-3AD203B41FA5}">
+                      <a16:colId xmlns:a16="http://schemas.microsoft.com/office/drawing/2014/main" val="20002"/>
+                    </a:ext>
+                  </a:extLst>
+                </a:gridCol>
+                <a:gridCol w="5029200">
+                  <a:extLst>
+                    <a:ext uri="{9D8B030D-6E8A-4147-A177-3AD203B41FA5}">
+                      <a16:colId xmlns:a16="http://schemas.microsoft.com/office/drawing/2014/main" val="20003"/>
+                    </a:ext>
+                  </a:extLst>
+                </a:gridCol>
               </a:tblGrid>
               <a:tr h="587828">
                 <a:tc>
@@ -9495,6 +9963,11 @@
                     </a:solidFill>
                   </a:tcPr>
                 </a:tc>
+                <a:extLst>
+                  <a:ext uri="{0D108BD9-81ED-4DB2-BD59-A6C34878D82A}">
+                    <a16:rowId xmlns:a16="http://schemas.microsoft.com/office/drawing/2014/main" val="10000"/>
+                  </a:ext>
+                </a:extLst>
               </a:tr>
               <a:tr h="587828">
                 <a:tc>
@@ -9577,6 +10050,11 @@
                   </a:txBody>
                   <a:tcPr/>
                 </a:tc>
+                <a:extLst>
+                  <a:ext uri="{0D108BD9-81ED-4DB2-BD59-A6C34878D82A}">
+                    <a16:rowId xmlns:a16="http://schemas.microsoft.com/office/drawing/2014/main" val="10001"/>
+                  </a:ext>
+                </a:extLst>
               </a:tr>
               <a:tr h="587828">
                 <a:tc>
@@ -9675,6 +10153,11 @@
                     </a:solidFill>
                   </a:tcPr>
                 </a:tc>
+                <a:extLst>
+                  <a:ext uri="{0D108BD9-81ED-4DB2-BD59-A6C34878D82A}">
+                    <a16:rowId xmlns:a16="http://schemas.microsoft.com/office/drawing/2014/main" val="10002"/>
+                  </a:ext>
+                </a:extLst>
               </a:tr>
               <a:tr h="587828">
                 <a:tc>
@@ -9757,6 +10240,11 @@
                   </a:txBody>
                   <a:tcPr/>
                 </a:tc>
+                <a:extLst>
+                  <a:ext uri="{0D108BD9-81ED-4DB2-BD59-A6C34878D82A}">
+                    <a16:rowId xmlns:a16="http://schemas.microsoft.com/office/drawing/2014/main" val="10003"/>
+                  </a:ext>
+                </a:extLst>
               </a:tr>
               <a:tr h="587828">
                 <a:tc>
@@ -9855,6 +10343,11 @@
                     </a:solidFill>
                   </a:tcPr>
                 </a:tc>
+                <a:extLst>
+                  <a:ext uri="{0D108BD9-81ED-4DB2-BD59-A6C34878D82A}">
+                    <a16:rowId xmlns:a16="http://schemas.microsoft.com/office/drawing/2014/main" val="10004"/>
+                  </a:ext>
+                </a:extLst>
               </a:tr>
               <a:tr h="587828">
                 <a:tc>
@@ -9937,6 +10430,11 @@
                   </a:txBody>
                   <a:tcPr/>
                 </a:tc>
+                <a:extLst>
+                  <a:ext uri="{0D108BD9-81ED-4DB2-BD59-A6C34878D82A}">
+                    <a16:rowId xmlns:a16="http://schemas.microsoft.com/office/drawing/2014/main" val="10005"/>
+                  </a:ext>
+                </a:extLst>
               </a:tr>
               <a:tr h="587832">
                 <a:tc>
@@ -10035,6 +10533,11 @@
                     </a:solidFill>
                   </a:tcPr>
                 </a:tc>
+                <a:extLst>
+                  <a:ext uri="{0D108BD9-81ED-4DB2-BD59-A6C34878D82A}">
+                    <a16:rowId xmlns:a16="http://schemas.microsoft.com/office/drawing/2014/main" val="10006"/>
+                  </a:ext>
+                </a:extLst>
               </a:tr>
             </a:tbl>
           </a:graphicData>
@@ -10080,6 +10583,7 @@
           <a:lstStyle/>
           <a:p>
             <a:pPr algn="ctr"/>
+            <a:endParaRPr/>
           </a:p>
         </p:txBody>
       </p:sp>

</xml_diff>

<commit_message>
Reframe 40 mm jaw opening as self-imposed team target, not MP1 requirement
The MP1 (Jordan Chen) brief specifies gripping a ~25 mm object with
5-8 N force and a ~20% scale-down from the BigClaw (0-86 mm range). It
does not state any numeric jaw-opening requirement. Updated MP4 Part B
and MP5 deliverables (including slides.pptx/pdf) so the >=40 mm jaw
opening is presented as a self-imposed team target rather than a brief
requirement. Also corrected the wrong-AI-moment narrative so the 25 mm
figure is attributed to David's own MP1 Part B design (sized to grip the
~25 mm object), not to the brief. Design selection is unchanged (Haben's
linkage).

Co-Authored-By: David Ricciotti <davidr73@uw.edu>
</commit_message>
<xml_diff>
--- a/MP5/slides.pptx
+++ b/MP5/slides.pptx
@@ -5049,7 +5049,7 @@
             </a:pPr>
             <a:r>
               <a:rPr dirty="0"/>
-              <a:t>Jaw opening: ≥ 40 mm</a:t>
+              <a:t>Grip target: close on a ~25 mm object</a:t>
             </a:r>
           </a:p>
           <a:p>
@@ -5135,6 +5135,23 @@
             <a:r>
               <a:rPr dirty="0"/>
               <a:t>Cost: &lt; $3/unit at 500-unit scale</a:t>
+            </a:r>
+          </a:p>
+          <a:p>
+            <a:pPr>
+              <a:spcAft>
+                <a:spcPts val="800"/>
+              </a:spcAft>
+              <a:defRPr sz="2200">
+                <a:solidFill>
+                  <a:srgbClr val="333333"/>
+                </a:solidFill>
+                <a:latin typeface="Calibri"/>
+              </a:defRPr>
+            </a:pPr>
+            <a:r>
+              <a:rPr dirty="0"/>
+              <a:t>Note: brief states no jaw opening — team set ≥40 mm as a self-imposed target</a:t>
             </a:r>
           </a:p>
         </p:txBody>
@@ -5214,7 +5231,7 @@
               </a:defRPr>
             </a:pPr>
             <a:r>
-              <a:t>"The BigClaw outsells us 3-to-1. Your MiniClaw needs to match its jaw range in half the volume."</a:t>
+              <a:t>"The BigClaw outsells us 3-to-1. Your MiniClaw has to feel just as capable in a package about 20% smaller."</a:t>
             </a:r>
           </a:p>
         </p:txBody>
@@ -5399,7 +5416,7 @@
               </a:defRPr>
             </a:pPr>
             <a:r>
-              <a:t>Final MiniClaw design vs. MP1 targets</a:t>
+              <a:t>Final MiniClaw design vs. targets (MP1 + team)</a:t>
             </a:r>
           </a:p>
         </p:txBody>
@@ -5491,7 +5508,7 @@
                         </a:defRPr>
                       </a:pPr>
                       <a:r>
-                        <a:t>MP1 Target</a:t>
+                        <a:t>Target</a:t>
                       </a:r>
                     </a:p>
                   </a:txBody>
@@ -5590,7 +5607,7 @@
                         </a:defRPr>
                       </a:pPr>
                       <a:r>
-                        <a:t>≥ 40 mm</a:t>
+                        <a:t>≥ 40 mm (team)</a:t>
                       </a:r>
                     </a:p>
                   </a:txBody>
@@ -9417,12 +9434,12 @@
               </a:defRPr>
             </a:pPr>
             <a:r>
-              <a:t>David's MP1 brief specified:</a:t>
+              <a:t>David's MP1 Part B design used:</a:t>
             </a:r>
             <a:br/>
             <a:br/>
             <a:r>
-              <a:t>• 25 mm jaw opening</a:t>
+              <a:t>• ~25 mm jaw opening (to grip a ~25 mm object)</a:t>
             </a:r>
             <a:br/>
             <a:r>
@@ -9435,7 +9452,7 @@
             <a:br/>
             <a:br/>
             <a:r>
-              <a:t>The AI had never seen the MP1 requirements document. It guessed the specs and built a plausible-looking but wrong design.</a:t>
+              <a:t>The AI had never seen David's MP1 work. It guessed the specs and built a plausible-looking but wrong design.</a:t>
             </a:r>
           </a:p>
         </p:txBody>

</xml_diff>